<commit_message>
Corrected the figure with sed reports
</commit_message>
<xml_diff>
--- a/chapter_04/figures/sed_ff_reports.pptx
+++ b/chapter_04/figures/sed_ff_reports.pptx
@@ -112,14 +112,6 @@
 </p:presentation>
 </file>
 
-<file path=ppt/revisionInfo.xml><?xml version="1.0" encoding="utf-8"?>
-<p1510:revInfo xmlns:a="http://schemas.openxmlformats.org/drawingml/2006/main" xmlns:r="http://schemas.openxmlformats.org/officeDocument/2006/relationships" xmlns:p1510="http://schemas.microsoft.com/office/powerpoint/2015/10/main">
-  <p1510:revLst>
-    <p1510:client id="{A940D973-A742-4AD8-97D9-9F5F906670B8}" v="40" dt="2025-06-10T23:13:42.219"/>
-  </p1510:revLst>
-</p1510:revInfo>
-</file>
-
 <file path=ppt/changesInfos/changesInfo1.xml><?xml version="1.0" encoding="utf-8"?>
 <pc:chgInfo xmlns:a="http://schemas.openxmlformats.org/drawingml/2006/main" xmlns:r="http://schemas.openxmlformats.org/officeDocument/2006/relationships" xmlns:ac="http://schemas.microsoft.com/office/drawing/2013/main/command" xmlns:pc="http://schemas.microsoft.com/office/powerpoint/2013/main/command">
   <pc:docChgLst>
@@ -17729,6 +17721,38 @@
             <ac:cxnSpMk id="1756" creationId="{8996DD07-FE09-9CBE-DA13-DE22B6DEC87C}"/>
           </ac:cxnSpMkLst>
         </pc:cxnChg>
+      </pc:sldChg>
+    </pc:docChg>
+  </pc:docChgLst>
+  <pc:docChgLst>
+    <pc:chgData name="Fatima Pillosu" userId="a6295d4dc9e22643" providerId="LiveId" clId="{589F9F2E-4BDD-4BF1-A1B3-66EE55BD7FF2}"/>
+    <pc:docChg chg="modSld">
+      <pc:chgData name="Fatima Pillosu" userId="a6295d4dc9e22643" providerId="LiveId" clId="{589F9F2E-4BDD-4BF1-A1B3-66EE55BD7FF2}" dt="2025-07-14T11:45:32.113" v="54" actId="20577"/>
+      <pc:docMkLst>
+        <pc:docMk/>
+      </pc:docMkLst>
+      <pc:sldChg chg="modSp mod">
+        <pc:chgData name="Fatima Pillosu" userId="a6295d4dc9e22643" providerId="LiveId" clId="{589F9F2E-4BDD-4BF1-A1B3-66EE55BD7FF2}" dt="2025-07-14T11:45:32.113" v="54" actId="20577"/>
+        <pc:sldMkLst>
+          <pc:docMk/>
+          <pc:sldMk cId="43451586" sldId="256"/>
+        </pc:sldMkLst>
+        <pc:spChg chg="mod">
+          <ac:chgData name="Fatima Pillosu" userId="a6295d4dc9e22643" providerId="LiveId" clId="{589F9F2E-4BDD-4BF1-A1B3-66EE55BD7FF2}" dt="2025-07-14T11:45:32.113" v="54" actId="20577"/>
+          <ac:spMkLst>
+            <pc:docMk/>
+            <pc:sldMk cId="43451586" sldId="256"/>
+            <ac:spMk id="1618" creationId="{27473D3D-5CBA-FFCC-A510-580B02810B68}"/>
+          </ac:spMkLst>
+        </pc:spChg>
+        <pc:spChg chg="mod">
+          <ac:chgData name="Fatima Pillosu" userId="a6295d4dc9e22643" providerId="LiveId" clId="{589F9F2E-4BDD-4BF1-A1B3-66EE55BD7FF2}" dt="2025-07-14T11:33:51.556" v="42" actId="20577"/>
+          <ac:spMkLst>
+            <pc:docMk/>
+            <pc:sldMk cId="43451586" sldId="256"/>
+            <ac:spMk id="1706" creationId="{44074D66-E01D-3CA8-43D7-933D0BD9040D}"/>
+          </ac:spMkLst>
+        </pc:spChg>
       </pc:sldChg>
     </pc:docChg>
   </pc:docChgLst>
@@ -20810,7 +20834,7 @@
           <a:p>
             <a:fld id="{26592153-C028-4DFF-87EE-E61A3F376311}" type="datetimeFigureOut">
               <a:rPr lang="en-GB" smtClean="0"/>
-              <a:t>11/06/2025</a:t>
+              <a:t>14/07/2025</a:t>
             </a:fld>
             <a:endParaRPr lang="en-GB"/>
           </a:p>
@@ -20980,7 +21004,7 @@
           <a:p>
             <a:fld id="{26592153-C028-4DFF-87EE-E61A3F376311}" type="datetimeFigureOut">
               <a:rPr lang="en-GB" smtClean="0"/>
-              <a:t>11/06/2025</a:t>
+              <a:t>14/07/2025</a:t>
             </a:fld>
             <a:endParaRPr lang="en-GB"/>
           </a:p>
@@ -21160,7 +21184,7 @@
           <a:p>
             <a:fld id="{26592153-C028-4DFF-87EE-E61A3F376311}" type="datetimeFigureOut">
               <a:rPr lang="en-GB" smtClean="0"/>
-              <a:t>11/06/2025</a:t>
+              <a:t>14/07/2025</a:t>
             </a:fld>
             <a:endParaRPr lang="en-GB"/>
           </a:p>
@@ -21330,7 +21354,7 @@
           <a:p>
             <a:fld id="{26592153-C028-4DFF-87EE-E61A3F376311}" type="datetimeFigureOut">
               <a:rPr lang="en-GB" smtClean="0"/>
-              <a:t>11/06/2025</a:t>
+              <a:t>14/07/2025</a:t>
             </a:fld>
             <a:endParaRPr lang="en-GB"/>
           </a:p>
@@ -21574,7 +21598,7 @@
           <a:p>
             <a:fld id="{26592153-C028-4DFF-87EE-E61A3F376311}" type="datetimeFigureOut">
               <a:rPr lang="en-GB" smtClean="0"/>
-              <a:t>11/06/2025</a:t>
+              <a:t>14/07/2025</a:t>
             </a:fld>
             <a:endParaRPr lang="en-GB"/>
           </a:p>
@@ -21806,7 +21830,7 @@
           <a:p>
             <a:fld id="{26592153-C028-4DFF-87EE-E61A3F376311}" type="datetimeFigureOut">
               <a:rPr lang="en-GB" smtClean="0"/>
-              <a:t>11/06/2025</a:t>
+              <a:t>14/07/2025</a:t>
             </a:fld>
             <a:endParaRPr lang="en-GB"/>
           </a:p>
@@ -22173,7 +22197,7 @@
           <a:p>
             <a:fld id="{26592153-C028-4DFF-87EE-E61A3F376311}" type="datetimeFigureOut">
               <a:rPr lang="en-GB" smtClean="0"/>
-              <a:t>11/06/2025</a:t>
+              <a:t>14/07/2025</a:t>
             </a:fld>
             <a:endParaRPr lang="en-GB"/>
           </a:p>
@@ -22291,7 +22315,7 @@
           <a:p>
             <a:fld id="{26592153-C028-4DFF-87EE-E61A3F376311}" type="datetimeFigureOut">
               <a:rPr lang="en-GB" smtClean="0"/>
-              <a:t>11/06/2025</a:t>
+              <a:t>14/07/2025</a:t>
             </a:fld>
             <a:endParaRPr lang="en-GB"/>
           </a:p>
@@ -22386,7 +22410,7 @@
           <a:p>
             <a:fld id="{26592153-C028-4DFF-87EE-E61A3F376311}" type="datetimeFigureOut">
               <a:rPr lang="en-GB" smtClean="0"/>
-              <a:t>11/06/2025</a:t>
+              <a:t>14/07/2025</a:t>
             </a:fld>
             <a:endParaRPr lang="en-GB"/>
           </a:p>
@@ -22663,7 +22687,7 @@
           <a:p>
             <a:fld id="{26592153-C028-4DFF-87EE-E61A3F376311}" type="datetimeFigureOut">
               <a:rPr lang="en-GB" smtClean="0"/>
-              <a:t>11/06/2025</a:t>
+              <a:t>14/07/2025</a:t>
             </a:fld>
             <a:endParaRPr lang="en-GB"/>
           </a:p>
@@ -22920,7 +22944,7 @@
           <a:p>
             <a:fld id="{26592153-C028-4DFF-87EE-E61A3F376311}" type="datetimeFigureOut">
               <a:rPr lang="en-GB" smtClean="0"/>
-              <a:t>11/06/2025</a:t>
+              <a:t>14/07/2025</a:t>
             </a:fld>
             <a:endParaRPr lang="en-GB"/>
           </a:p>
@@ -23133,7 +23157,7 @@
           <a:p>
             <a:fld id="{26592153-C028-4DFF-87EE-E61A3F376311}" type="datetimeFigureOut">
               <a:rPr lang="en-GB" smtClean="0"/>
-              <a:t>11/06/2025</a:t>
+              <a:t>14/07/2025</a:t>
             </a:fld>
             <a:endParaRPr lang="en-GB"/>
           </a:p>
@@ -27338,13 +27362,22 @@
           </a:p>
           <a:p>
             <a:r>
+              <a:rPr lang="en-US" sz="800">
+                <a:solidFill>
+                  <a:srgbClr val="0000FF"/>
+                </a:solidFill>
+                <a:latin typeface="+mj-lt"/>
+              </a:rPr>
+              <a:t>2021-09-02 </a:t>
+            </a:r>
+            <a:r>
               <a:rPr lang="en-US" sz="800" dirty="0">
                 <a:solidFill>
                   <a:srgbClr val="0000FF"/>
                 </a:solidFill>
                 <a:latin typeface="+mj-lt"/>
               </a:rPr>
-              <a:t>02-09-2021 at 00 UTC</a:t>
+              <a:t>at 00 UTC</a:t>
             </a:r>
           </a:p>
           <a:p>
@@ -27572,7 +27605,7 @@
         <p:spPr>
           <a:xfrm>
             <a:off x="-78814" y="349275"/>
-            <a:ext cx="2120029" cy="461665"/>
+            <a:ext cx="2120029" cy="584775"/>
           </a:xfrm>
           <a:prstGeom prst="rect">
             <a:avLst/>
@@ -27592,7 +27625,7 @@
                 </a:solidFill>
                 <a:latin typeface="+mj-lt"/>
               </a:rPr>
-              <a:t>a) Spatial distribution for the frequency of point flash flood impact report counts per grid-box, between 2001 and 2024</a:t>
+              <a:t>a) Spatial distribution of the frequency of point flash flood impact report counts in each ERA5 grid-box within the CONUS, between 2001 and 2024</a:t>
             </a:r>
           </a:p>
         </p:txBody>

</xml_diff>